<commit_message>
Remoção de ficheiros desnecessários e atualização de imagens no ppt
</commit_message>
<xml_diff>
--- a/VitalRoutePPT.pptx
+++ b/VitalRoutePPT.pptx
@@ -4000,6 +4000,36 @@
           </a:p>
         </p:txBody>
       </p:sp>
+      <p:pic>
+        <p:nvPicPr>
+          <p:cNvPr id="50" name="Imagem 49">
+            <a:extLst>
+              <a:ext uri="{FF2B5EF4-FFF2-40B4-BE49-F238E27FC236}">
+                <a16:creationId xmlns:a16="http://schemas.microsoft.com/office/drawing/2014/main" id="{29AC1AD1-F09E-BF0F-0E5B-6946FE1E0C91}"/>
+              </a:ext>
+            </a:extLst>
+          </p:cNvPr>
+          <p:cNvPicPr>
+            <a:picLocks noChangeAspect="1"/>
+          </p:cNvPicPr>
+          <p:nvPr/>
+        </p:nvPicPr>
+        <p:blipFill>
+          <a:blip r:embed="rId4"/>
+          <a:stretch>
+            <a:fillRect/>
+          </a:stretch>
+        </p:blipFill>
+        <p:spPr>
+          <a:xfrm>
+            <a:off x="4429125" y="1487480"/>
+            <a:ext cx="4381428" cy="2075744"/>
+          </a:xfrm>
+          <a:prstGeom prst="rect">
+            <a:avLst/>
+          </a:prstGeom>
+        </p:spPr>
+      </p:pic>
     </p:spTree>
   </p:cSld>
   <p:clrMapOvr>
@@ -5796,7 +5826,7 @@
         <p:spPr>
           <a:xfrm>
             <a:off x="6229350" y="2721099"/>
-            <a:ext cx="2143125" cy="241436"/>
+            <a:ext cx="2143125" cy="100027"/>
           </a:xfrm>
           <a:prstGeom prst="rect">
             <a:avLst/>
@@ -5825,7 +5855,7 @@
                 <a:ea typeface="Inter" pitchFamily="34" charset="-122"/>
                 <a:cs typeface="Inter" pitchFamily="34" charset="-120"/>
               </a:rPr>
-              <a:t>[INSERIR SCREENSHOT: SosSlider em ação durante uma atividade]</a:t>
+              <a:t>[</a:t>
             </a:r>
             <a:endParaRPr lang="en-US" sz="650" dirty="0"/>
           </a:p>
@@ -7306,6 +7336,36 @@
           </a:p>
         </p:txBody>
       </p:sp>
+      <p:pic>
+        <p:nvPicPr>
+          <p:cNvPr id="93" name="Imagem 92">
+            <a:extLst>
+              <a:ext uri="{FF2B5EF4-FFF2-40B4-BE49-F238E27FC236}">
+                <a16:creationId xmlns:a16="http://schemas.microsoft.com/office/drawing/2014/main" id="{F8BE39BA-7266-B03C-C075-941A5F7C6371}"/>
+              </a:ext>
+            </a:extLst>
+          </p:cNvPr>
+          <p:cNvPicPr>
+            <a:picLocks noChangeAspect="1"/>
+          </p:cNvPicPr>
+          <p:nvPr/>
+        </p:nvPicPr>
+        <p:blipFill>
+          <a:blip r:embed="rId4"/>
+          <a:stretch>
+            <a:fillRect/>
+          </a:stretch>
+        </p:blipFill>
+        <p:spPr>
+          <a:xfrm>
+            <a:off x="5886450" y="1459467"/>
+            <a:ext cx="2840417" cy="1376155"/>
+          </a:xfrm>
+          <a:prstGeom prst="rect">
+            <a:avLst/>
+          </a:prstGeom>
+        </p:spPr>
+      </p:pic>
     </p:spTree>
   </p:cSld>
   <p:clrMapOvr>
@@ -13631,8 +13691,8 @@
         </p:nvSpPr>
         <p:spPr>
           <a:xfrm>
-            <a:off x="3836166" y="3982194"/>
-            <a:ext cx="1471613" cy="141424"/>
+            <a:off x="4345148" y="3982194"/>
+            <a:ext cx="453650" cy="121893"/>
           </a:xfrm>
           <a:prstGeom prst="rect">
             <a:avLst/>
@@ -13653,15 +13713,14 @@
               <a:buNone/>
             </a:pPr>
             <a:r>
-              <a:rPr lang="en-US" sz="900" b="1" dirty="0">
+              <a:rPr lang="en-US" sz="900" b="1" dirty="0" err="1">
                 <a:solidFill>
                   <a:srgbClr val="F5F5F7"/>
                 </a:solidFill>
                 <a:latin typeface="Inter ExtraBold" pitchFamily="34" charset="0"/>
                 <a:ea typeface="Inter ExtraBold" pitchFamily="34" charset="-122"/>
-                <a:cs typeface="Inter ExtraBold" pitchFamily="34" charset="-120"/>
-              </a:rPr>
-              <a:t>Iniciar</a:t>
+              </a:rPr>
+              <a:t>Gravação</a:t>
             </a:r>
             <a:endParaRPr lang="en-US" sz="900" dirty="0"/>
           </a:p>
@@ -14125,8 +14184,8 @@
         </p:nvSpPr>
         <p:spPr>
           <a:xfrm>
-            <a:off x="7185161" y="3982194"/>
-            <a:ext cx="1471613" cy="141424"/>
+            <a:off x="7793529" y="3982194"/>
+            <a:ext cx="254878" cy="121893"/>
           </a:xfrm>
           <a:prstGeom prst="rect">
             <a:avLst/>
@@ -14147,7 +14206,7 @@
               <a:buNone/>
             </a:pPr>
             <a:r>
-              <a:rPr lang="en-US" sz="900" b="1" dirty="0">
+              <a:rPr lang="en-US" sz="900" b="1" dirty="0" err="1">
                 <a:solidFill>
                   <a:srgbClr val="F5F5F7"/>
                 </a:solidFill>
@@ -14155,7 +14214,7 @@
                 <a:ea typeface="Inter ExtraBold" pitchFamily="34" charset="-122"/>
                 <a:cs typeface="Inter ExtraBold" pitchFamily="34" charset="-120"/>
               </a:rPr>
-              <a:t>Diário</a:t>
+              <a:t>Perfil</a:t>
             </a:r>
             <a:endParaRPr lang="en-US" sz="900" dirty="0"/>
           </a:p>
@@ -14343,6 +14402,156 @@
           </a:p>
         </p:txBody>
       </p:sp>
+      <p:pic>
+        <p:nvPicPr>
+          <p:cNvPr id="46" name="Imagem 45">
+            <a:extLst>
+              <a:ext uri="{FF2B5EF4-FFF2-40B4-BE49-F238E27FC236}">
+                <a16:creationId xmlns:a16="http://schemas.microsoft.com/office/drawing/2014/main" id="{608CC0EE-7425-9D37-BEBB-8C5E2049552F}"/>
+              </a:ext>
+            </a:extLst>
+          </p:cNvPr>
+          <p:cNvPicPr>
+            <a:picLocks noChangeAspect="1"/>
+          </p:cNvPicPr>
+          <p:nvPr/>
+        </p:nvPicPr>
+        <p:blipFill>
+          <a:blip r:embed="rId4"/>
+          <a:stretch>
+            <a:fillRect/>
+          </a:stretch>
+        </p:blipFill>
+        <p:spPr>
+          <a:xfrm>
+            <a:off x="594326" y="1510429"/>
+            <a:ext cx="1257300" cy="2357466"/>
+          </a:xfrm>
+          <a:prstGeom prst="rect">
+            <a:avLst/>
+          </a:prstGeom>
+        </p:spPr>
+      </p:pic>
+      <p:pic>
+        <p:nvPicPr>
+          <p:cNvPr id="48" name="Imagem 47">
+            <a:extLst>
+              <a:ext uri="{FF2B5EF4-FFF2-40B4-BE49-F238E27FC236}">
+                <a16:creationId xmlns:a16="http://schemas.microsoft.com/office/drawing/2014/main" id="{10CF1012-435A-DBFC-04B8-11A602F17D11}"/>
+              </a:ext>
+            </a:extLst>
+          </p:cNvPr>
+          <p:cNvPicPr>
+            <a:picLocks noChangeAspect="1"/>
+          </p:cNvPicPr>
+          <p:nvPr/>
+        </p:nvPicPr>
+        <p:blipFill>
+          <a:blip r:embed="rId5"/>
+          <a:stretch>
+            <a:fillRect/>
+          </a:stretch>
+        </p:blipFill>
+        <p:spPr>
+          <a:xfrm>
+            <a:off x="2268810" y="1510457"/>
+            <a:ext cx="1278332" cy="2357438"/>
+          </a:xfrm>
+          <a:prstGeom prst="rect">
+            <a:avLst/>
+          </a:prstGeom>
+        </p:spPr>
+      </p:pic>
+      <p:pic>
+        <p:nvPicPr>
+          <p:cNvPr id="50" name="Imagem 49">
+            <a:extLst>
+              <a:ext uri="{FF2B5EF4-FFF2-40B4-BE49-F238E27FC236}">
+                <a16:creationId xmlns:a16="http://schemas.microsoft.com/office/drawing/2014/main" id="{57EA626A-0F8A-0DE4-263E-085C52D0C7BB}"/>
+              </a:ext>
+            </a:extLst>
+          </p:cNvPr>
+          <p:cNvPicPr>
+            <a:picLocks noChangeAspect="1"/>
+          </p:cNvPicPr>
+          <p:nvPr/>
+        </p:nvPicPr>
+        <p:blipFill>
+          <a:blip r:embed="rId6"/>
+          <a:stretch>
+            <a:fillRect/>
+          </a:stretch>
+        </p:blipFill>
+        <p:spPr>
+          <a:xfrm>
+            <a:off x="3925768" y="1515055"/>
+            <a:ext cx="1284005" cy="2352840"/>
+          </a:xfrm>
+          <a:prstGeom prst="rect">
+            <a:avLst/>
+          </a:prstGeom>
+        </p:spPr>
+      </p:pic>
+      <p:pic>
+        <p:nvPicPr>
+          <p:cNvPr id="52" name="Imagem 51">
+            <a:extLst>
+              <a:ext uri="{FF2B5EF4-FFF2-40B4-BE49-F238E27FC236}">
+                <a16:creationId xmlns:a16="http://schemas.microsoft.com/office/drawing/2014/main" id="{372C1A5F-48FA-CFC5-C085-ABC0B7D1D386}"/>
+              </a:ext>
+            </a:extLst>
+          </p:cNvPr>
+          <p:cNvPicPr>
+            <a:picLocks noChangeAspect="1"/>
+          </p:cNvPicPr>
+          <p:nvPr/>
+        </p:nvPicPr>
+        <p:blipFill>
+          <a:blip r:embed="rId7"/>
+          <a:stretch>
+            <a:fillRect/>
+          </a:stretch>
+        </p:blipFill>
+        <p:spPr>
+          <a:xfrm>
+            <a:off x="5625098" y="1512177"/>
+            <a:ext cx="1255502" cy="2355718"/>
+          </a:xfrm>
+          <a:prstGeom prst="rect">
+            <a:avLst/>
+          </a:prstGeom>
+        </p:spPr>
+      </p:pic>
+      <p:pic>
+        <p:nvPicPr>
+          <p:cNvPr id="54" name="Imagem 53">
+            <a:extLst>
+              <a:ext uri="{FF2B5EF4-FFF2-40B4-BE49-F238E27FC236}">
+                <a16:creationId xmlns:a16="http://schemas.microsoft.com/office/drawing/2014/main" id="{F19948AD-B66C-897C-91C3-E51ABB52F74D}"/>
+              </a:ext>
+            </a:extLst>
+          </p:cNvPr>
+          <p:cNvPicPr>
+            <a:picLocks noChangeAspect="1"/>
+          </p:cNvPicPr>
+          <p:nvPr/>
+        </p:nvPicPr>
+        <p:blipFill>
+          <a:blip r:embed="rId8"/>
+          <a:stretch>
+            <a:fillRect/>
+          </a:stretch>
+        </p:blipFill>
+        <p:spPr>
+          <a:xfrm>
+            <a:off x="7283196" y="1515055"/>
+            <a:ext cx="1255502" cy="2352840"/>
+          </a:xfrm>
+          <a:prstGeom prst="rect">
+            <a:avLst/>
+          </a:prstGeom>
+        </p:spPr>
+      </p:pic>
     </p:spTree>
   </p:cSld>
   <p:clrMapOvr>
@@ -17027,27 +17236,24 @@
       </p:sp>
       <p:sp>
         <p:nvSpPr>
-          <p:cNvPr id="25" name="Shape 22"/>
-          <p:cNvSpPr/>
-          <p:nvPr/>
-        </p:nvSpPr>
-        <p:spPr>
-          <a:xfrm>
-            <a:off x="5800725" y="828675"/>
-            <a:ext cx="3000375" cy="2714625"/>
-          </a:xfrm>
-          <a:prstGeom prst="rect">
-            <a:avLst/>
-          </a:prstGeom>
-          <a:solidFill>
-            <a:srgbClr val="101015"/>
-          </a:solidFill>
-          <a:ln w="9144">
-            <a:solidFill>
-              <a:srgbClr val="6B7280"/>
-            </a:solidFill>
-            <a:prstDash val="dash"/>
-          </a:ln>
+          <p:cNvPr id="34" name="Shape 31"/>
+          <p:cNvSpPr/>
+          <p:nvPr/>
+        </p:nvSpPr>
+        <p:spPr>
+          <a:xfrm>
+            <a:off x="457200" y="4257675"/>
+            <a:ext cx="8229600" cy="514350"/>
+          </a:xfrm>
+          <a:prstGeom prst="rect">
+            <a:avLst/>
+          </a:prstGeom>
+          <a:solidFill>
+            <a:srgbClr val="000000">
+              <a:alpha val="0"/>
+            </a:srgbClr>
+          </a:solidFill>
+          <a:ln/>
         </p:spPr>
         <p:txBody>
           <a:bodyPr/>
@@ -17059,14 +17265,41 @@
       </p:sp>
       <p:sp>
         <p:nvSpPr>
-          <p:cNvPr id="26" name="Text 23"/>
-          <p:cNvSpPr/>
-          <p:nvPr/>
-        </p:nvSpPr>
-        <p:spPr>
-          <a:xfrm>
-            <a:off x="6445588" y="971550"/>
-            <a:ext cx="1710649" cy="121444"/>
+          <p:cNvPr id="35" name="Shape 32"/>
+          <p:cNvSpPr/>
+          <p:nvPr/>
+        </p:nvSpPr>
+        <p:spPr>
+          <a:xfrm>
+            <a:off x="457200" y="4257675"/>
+            <a:ext cx="8229600" cy="7144"/>
+          </a:xfrm>
+          <a:prstGeom prst="rect">
+            <a:avLst/>
+          </a:prstGeom>
+          <a:solidFill>
+            <a:srgbClr val="FFFFFF"/>
+          </a:solidFill>
+          <a:ln/>
+        </p:spPr>
+        <p:txBody>
+          <a:bodyPr/>
+          <a:lstStyle/>
+          <a:p>
+            <a:endParaRPr lang="es-ES"/>
+          </a:p>
+        </p:txBody>
+      </p:sp>
+      <p:sp>
+        <p:nvSpPr>
+          <p:cNvPr id="36" name="Text 33"/>
+          <p:cNvSpPr/>
+          <p:nvPr/>
+        </p:nvSpPr>
+        <p:spPr>
+          <a:xfrm>
+            <a:off x="457200" y="4454128"/>
+            <a:ext cx="1680567" cy="121444"/>
           </a:xfrm>
           <a:prstGeom prst="rect">
             <a:avLst/>
@@ -17084,334 +17317,39 @@
               <a:buNone/>
             </a:pPr>
             <a:r>
-              <a:rPr lang="en-US" sz="700" b="1" kern="0" spc="1" dirty="0">
-                <a:solidFill>
-                  <a:srgbClr val="FF6B35"/>
-                </a:solidFill>
-                <a:latin typeface="Inter ExtraBold" pitchFamily="34" charset="0"/>
-                <a:ea typeface="Inter ExtraBold" pitchFamily="34" charset="-122"/>
-                <a:cs typeface="Inter ExtraBold" pitchFamily="34" charset="-120"/>
-              </a:rPr>
-              <a:t>PLACEHOLDER SCREENSHOT</a:t>
-            </a:r>
-            <a:endParaRPr lang="en-US" sz="700" dirty="0"/>
-          </a:p>
-        </p:txBody>
-      </p:sp>
-      <p:sp>
-        <p:nvSpPr>
-          <p:cNvPr id="27" name="Shape 24"/>
-          <p:cNvSpPr/>
-          <p:nvPr/>
-        </p:nvSpPr>
-        <p:spPr>
-          <a:xfrm>
-            <a:off x="6522244" y="1207294"/>
-            <a:ext cx="1557338" cy="1960959"/>
-          </a:xfrm>
-          <a:prstGeom prst="rect">
-            <a:avLst/>
-          </a:prstGeom>
-          <a:solidFill>
-            <a:srgbClr val="111116"/>
-          </a:solidFill>
-          <a:ln w="18288">
-            <a:solidFill>
-              <a:srgbClr val="2F3038"/>
-            </a:solidFill>
-            <a:prstDash val="solid"/>
-          </a:ln>
-        </p:spPr>
-        <p:txBody>
-          <a:bodyPr/>
-          <a:lstStyle/>
-          <a:p>
-            <a:endParaRPr lang="es-ES"/>
-          </a:p>
-        </p:txBody>
-      </p:sp>
-      <p:sp>
-        <p:nvSpPr>
-          <p:cNvPr id="28" name="Shape 25"/>
-          <p:cNvSpPr/>
-          <p:nvPr/>
-        </p:nvSpPr>
-        <p:spPr>
-          <a:xfrm>
-            <a:off x="6679406" y="1464469"/>
-            <a:ext cx="1243013" cy="271463"/>
-          </a:xfrm>
-          <a:prstGeom prst="rect">
-            <a:avLst/>
-          </a:prstGeom>
-          <a:solidFill>
-            <a:srgbClr val="1D1D25"/>
-          </a:solidFill>
-          <a:ln/>
-        </p:spPr>
-        <p:txBody>
-          <a:bodyPr/>
-          <a:lstStyle/>
-          <a:p>
-            <a:endParaRPr lang="es-ES"/>
-          </a:p>
-        </p:txBody>
-      </p:sp>
-      <p:sp>
-        <p:nvSpPr>
-          <p:cNvPr id="29" name="Shape 26"/>
-          <p:cNvSpPr/>
-          <p:nvPr/>
-        </p:nvSpPr>
-        <p:spPr>
-          <a:xfrm>
-            <a:off x="6679406" y="1464469"/>
-            <a:ext cx="1243013" cy="21431"/>
-          </a:xfrm>
-          <a:prstGeom prst="rect">
-            <a:avLst/>
-          </a:prstGeom>
-          <a:solidFill>
-            <a:srgbClr val="FF6B35"/>
-          </a:solidFill>
-          <a:ln/>
-        </p:spPr>
-        <p:txBody>
-          <a:bodyPr/>
-          <a:lstStyle/>
-          <a:p>
-            <a:endParaRPr lang="es-ES"/>
-          </a:p>
-        </p:txBody>
-      </p:sp>
-      <p:sp>
-        <p:nvSpPr>
-          <p:cNvPr id="30" name="Text 27"/>
-          <p:cNvSpPr/>
-          <p:nvPr/>
-        </p:nvSpPr>
-        <p:spPr>
-          <a:xfrm>
-            <a:off x="6679406" y="1464469"/>
-            <a:ext cx="1243013" cy="271463"/>
-          </a:xfrm>
-          <a:prstGeom prst="rect">
-            <a:avLst/>
-          </a:prstGeom>
-          <a:noFill/>
-          <a:ln/>
-        </p:spPr>
-        <p:txBody>
-          <a:bodyPr wrap="none" lIns="0" tIns="0" rIns="0" bIns="0" rtlCol="0" anchor="ctr">
-            <a:spAutoFit/>
-          </a:bodyPr>
-          <a:lstStyle/>
-          <a:p>
-            <a:pPr marL="0" indent="0" algn="ctr">
-              <a:buNone/>
-            </a:pPr>
-            <a:r>
-              <a:rPr lang="en-US" sz="700" b="1" dirty="0">
-                <a:solidFill>
-                  <a:srgbClr val="F5F5F7"/>
-                </a:solidFill>
-                <a:latin typeface="Inter Bold" pitchFamily="34" charset="0"/>
-                <a:ea typeface="Inter Bold" pitchFamily="34" charset="-122"/>
-                <a:cs typeface="Inter Bold" pitchFamily="34" charset="-120"/>
-              </a:rPr>
-              <a:t>HomeScreen</a:t>
-            </a:r>
-            <a:endParaRPr lang="en-US" sz="700" dirty="0"/>
-          </a:p>
-        </p:txBody>
-      </p:sp>
-      <p:sp>
-        <p:nvSpPr>
-          <p:cNvPr id="31" name="Shape 28"/>
-          <p:cNvSpPr/>
-          <p:nvPr/>
-        </p:nvSpPr>
-        <p:spPr>
-          <a:xfrm>
-            <a:off x="6679406" y="2764631"/>
-            <a:ext cx="1243013" cy="228600"/>
-          </a:xfrm>
-          <a:prstGeom prst="rect">
-            <a:avLst/>
-          </a:prstGeom>
-          <a:solidFill>
-            <a:srgbClr val="241812"/>
-          </a:solidFill>
-          <a:ln/>
-        </p:spPr>
-        <p:txBody>
-          <a:bodyPr/>
-          <a:lstStyle/>
-          <a:p>
-            <a:endParaRPr lang="es-ES"/>
-          </a:p>
-        </p:txBody>
-      </p:sp>
-      <p:sp>
-        <p:nvSpPr>
-          <p:cNvPr id="32" name="Text 29"/>
-          <p:cNvSpPr/>
-          <p:nvPr/>
-        </p:nvSpPr>
-        <p:spPr>
-          <a:xfrm>
-            <a:off x="6679406" y="2764631"/>
-            <a:ext cx="1243013" cy="228600"/>
-          </a:xfrm>
-          <a:prstGeom prst="rect">
-            <a:avLst/>
-          </a:prstGeom>
-          <a:noFill/>
-          <a:ln/>
-        </p:spPr>
-        <p:txBody>
-          <a:bodyPr wrap="none" lIns="0" tIns="0" rIns="0" bIns="0" rtlCol="0" anchor="ctr">
-            <a:spAutoFit/>
-          </a:bodyPr>
-          <a:lstStyle/>
-          <a:p>
-            <a:pPr marL="0" indent="0" algn="ctr">
-              <a:buNone/>
-            </a:pPr>
-            <a:r>
-              <a:rPr lang="en-US" sz="650" b="1" dirty="0">
-                <a:solidFill>
-                  <a:srgbClr val="FF6B35"/>
-                </a:solidFill>
-                <a:latin typeface="Inter ExtraBold" pitchFamily="34" charset="0"/>
-                <a:ea typeface="Inter ExtraBold" pitchFamily="34" charset="-122"/>
-                <a:cs typeface="Inter ExtraBold" pitchFamily="34" charset="-120"/>
-              </a:rPr>
-              <a:t>BOTTOM NAV</a:t>
-            </a:r>
-            <a:endParaRPr lang="en-US" sz="650" dirty="0"/>
-          </a:p>
-        </p:txBody>
-      </p:sp>
-      <p:sp>
-        <p:nvSpPr>
-          <p:cNvPr id="33" name="Text 30"/>
-          <p:cNvSpPr/>
-          <p:nvPr/>
-        </p:nvSpPr>
-        <p:spPr>
-          <a:xfrm>
-            <a:off x="6157913" y="3253978"/>
-            <a:ext cx="2286000" cy="289322"/>
-          </a:xfrm>
-          <a:prstGeom prst="rect">
-            <a:avLst/>
-          </a:prstGeom>
-          <a:noFill/>
-          <a:ln/>
-        </p:spPr>
-        <p:txBody>
-          <a:bodyPr wrap="square" lIns="0" tIns="0" rIns="0" bIns="0" rtlCol="0" anchor="t">
-            <a:spAutoFit/>
-          </a:bodyPr>
-          <a:lstStyle/>
-          <a:p>
-            <a:pPr marL="0" indent="0" algn="ctr">
-              <a:lnSpc>
-                <a:spcPct val="108000"/>
-              </a:lnSpc>
-              <a:buNone/>
-            </a:pPr>
-            <a:r>
-              <a:rPr lang="en-US" sz="800" dirty="0">
-                <a:solidFill>
-                  <a:srgbClr val="A1A1AA"/>
+              <a:rPr lang="en-US" sz="750" dirty="0">
+                <a:solidFill>
+                  <a:srgbClr val="777985"/>
                 </a:solidFill>
                 <a:latin typeface="Inter" pitchFamily="34" charset="0"/>
                 <a:ea typeface="Inter" pitchFamily="34" charset="-122"/>
                 <a:cs typeface="Inter" pitchFamily="34" charset="-120"/>
               </a:rPr>
-              <a:t>[INSERIR SCREENSHOT: HomeScreen com dashboard semanal e estado dos sensores]</a:t>
-            </a:r>
-            <a:endParaRPr lang="en-US" sz="800" dirty="0"/>
-          </a:p>
-        </p:txBody>
-      </p:sp>
-      <p:sp>
-        <p:nvSpPr>
-          <p:cNvPr id="34" name="Shape 31"/>
-          <p:cNvSpPr/>
-          <p:nvPr/>
-        </p:nvSpPr>
-        <p:spPr>
-          <a:xfrm>
-            <a:off x="457200" y="4257675"/>
-            <a:ext cx="8229600" cy="514350"/>
-          </a:xfrm>
-          <a:prstGeom prst="rect">
-            <a:avLst/>
-          </a:prstGeom>
-          <a:solidFill>
-            <a:srgbClr val="000000">
-              <a:alpha val="0"/>
-            </a:srgbClr>
-          </a:solidFill>
-          <a:ln/>
-        </p:spPr>
-        <p:txBody>
-          <a:bodyPr/>
-          <a:lstStyle/>
-          <a:p>
-            <a:endParaRPr lang="es-ES"/>
-          </a:p>
-        </p:txBody>
-      </p:sp>
-      <p:sp>
-        <p:nvSpPr>
-          <p:cNvPr id="35" name="Shape 32"/>
-          <p:cNvSpPr/>
-          <p:nvPr/>
-        </p:nvSpPr>
-        <p:spPr>
-          <a:xfrm>
-            <a:off x="457200" y="4257675"/>
-            <a:ext cx="8229600" cy="7144"/>
-          </a:xfrm>
-          <a:prstGeom prst="rect">
-            <a:avLst/>
-          </a:prstGeom>
-          <a:solidFill>
-            <a:srgbClr val="FFFFFF"/>
-          </a:solidFill>
-          <a:ln/>
-        </p:spPr>
-        <p:txBody>
-          <a:bodyPr/>
-          <a:lstStyle/>
-          <a:p>
-            <a:endParaRPr lang="es-ES"/>
-          </a:p>
-        </p:txBody>
-      </p:sp>
-      <p:sp>
-        <p:nvSpPr>
-          <p:cNvPr id="36" name="Text 33"/>
-          <p:cNvSpPr/>
-          <p:nvPr/>
-        </p:nvSpPr>
-        <p:spPr>
-          <a:xfrm>
-            <a:off x="457200" y="4454128"/>
-            <a:ext cx="1680567" cy="121444"/>
-          </a:xfrm>
-          <a:prstGeom prst="rect">
-            <a:avLst/>
-          </a:prstGeom>
-          <a:noFill/>
-          <a:ln/>
-        </p:spPr>
-        <p:txBody>
-          <a:bodyPr wrap="square" lIns="0" tIns="0" rIns="0" bIns="0" rtlCol="0" anchor="t">
+              <a:t>VitalRoute · ICM 2025/26 · UA-DETI</a:t>
+            </a:r>
+            <a:endParaRPr lang="en-US" sz="750" dirty="0"/>
+          </a:p>
+        </p:txBody>
+      </p:sp>
+      <p:sp>
+        <p:nvSpPr>
+          <p:cNvPr id="37" name="Text 34"/>
+          <p:cNvSpPr/>
+          <p:nvPr/>
+        </p:nvSpPr>
+        <p:spPr>
+          <a:xfrm>
+            <a:off x="8367117" y="4454128"/>
+            <a:ext cx="319683" cy="121444"/>
+          </a:xfrm>
+          <a:prstGeom prst="rect">
+            <a:avLst/>
+          </a:prstGeom>
+          <a:noFill/>
+          <a:ln/>
+        </p:spPr>
+        <p:txBody>
+          <a:bodyPr wrap="none" lIns="0" tIns="0" rIns="0" bIns="0" rtlCol="0" anchor="t">
             <a:spAutoFit/>
           </a:bodyPr>
           <a:lstStyle/>
@@ -17428,53 +17366,42 @@
                 <a:ea typeface="Inter" pitchFamily="34" charset="-122"/>
                 <a:cs typeface="Inter" pitchFamily="34" charset="-120"/>
               </a:rPr>
-              <a:t>VitalRoute · ICM 2025/26 · UA-DETI</a:t>
+              <a:t>06 / 12</a:t>
             </a:r>
             <a:endParaRPr lang="en-US" sz="750" dirty="0"/>
           </a:p>
         </p:txBody>
       </p:sp>
-      <p:sp>
-        <p:nvSpPr>
-          <p:cNvPr id="37" name="Text 34"/>
-          <p:cNvSpPr/>
-          <p:nvPr/>
-        </p:nvSpPr>
-        <p:spPr>
-          <a:xfrm>
-            <a:off x="8367117" y="4454128"/>
-            <a:ext cx="319683" cy="121444"/>
-          </a:xfrm>
-          <a:prstGeom prst="rect">
-            <a:avLst/>
-          </a:prstGeom>
-          <a:noFill/>
-          <a:ln/>
-        </p:spPr>
-        <p:txBody>
-          <a:bodyPr wrap="none" lIns="0" tIns="0" rIns="0" bIns="0" rtlCol="0" anchor="t">
-            <a:spAutoFit/>
-          </a:bodyPr>
-          <a:lstStyle/>
-          <a:p>
-            <a:pPr marL="0" indent="0" algn="l">
-              <a:buNone/>
-            </a:pPr>
-            <a:r>
-              <a:rPr lang="en-US" sz="750" dirty="0">
-                <a:solidFill>
-                  <a:srgbClr val="777985"/>
-                </a:solidFill>
-                <a:latin typeface="Inter" pitchFamily="34" charset="0"/>
-                <a:ea typeface="Inter" pitchFamily="34" charset="-122"/>
-                <a:cs typeface="Inter" pitchFamily="34" charset="-120"/>
-              </a:rPr>
-              <a:t>06 / 12</a:t>
-            </a:r>
-            <a:endParaRPr lang="en-US" sz="750" dirty="0"/>
-          </a:p>
-        </p:txBody>
-      </p:sp>
+      <p:pic>
+        <p:nvPicPr>
+          <p:cNvPr id="40" name="Imagem 39">
+            <a:extLst>
+              <a:ext uri="{FF2B5EF4-FFF2-40B4-BE49-F238E27FC236}">
+                <a16:creationId xmlns:a16="http://schemas.microsoft.com/office/drawing/2014/main" id="{42AC6346-DFD2-C270-4B13-178C7342A044}"/>
+              </a:ext>
+            </a:extLst>
+          </p:cNvPr>
+          <p:cNvPicPr>
+            <a:picLocks noChangeAspect="1"/>
+          </p:cNvPicPr>
+          <p:nvPr/>
+        </p:nvPicPr>
+        <p:blipFill>
+          <a:blip r:embed="rId4"/>
+          <a:stretch>
+            <a:fillRect/>
+          </a:stretch>
+        </p:blipFill>
+        <p:spPr>
+          <a:xfrm>
+            <a:off x="5659119" y="806478"/>
+            <a:ext cx="3200401" cy="2967974"/>
+          </a:xfrm>
+          <a:prstGeom prst="rect">
+            <a:avLst/>
+          </a:prstGeom>
+        </p:spPr>
+      </p:pic>
     </p:spTree>
   </p:cSld>
   <p:clrMapOvr>
@@ -22907,7 +22834,7 @@
         <p:spPr>
           <a:xfrm>
             <a:off x="5807869" y="3607594"/>
-            <a:ext cx="2428875" cy="260021"/>
+            <a:ext cx="2428875" cy="115416"/>
           </a:xfrm>
           <a:prstGeom prst="rect">
             <a:avLst/>
@@ -22936,7 +22863,7 @@
                 <a:ea typeface="Inter" pitchFamily="34" charset="-122"/>
                 <a:cs typeface="Inter" pitchFamily="34" charset="-120"/>
               </a:rPr>
-              <a:t>[INSERIR SCREENSHOT: MapsScreen com camada CyclOSM e localização atual]</a:t>
+              <a:t>]</a:t>
             </a:r>
             <a:endParaRPr lang="en-US" sz="750" dirty="0"/>
           </a:p>
@@ -23230,6 +23157,36 @@
           </a:p>
         </p:txBody>
       </p:sp>
+      <p:pic>
+        <p:nvPicPr>
+          <p:cNvPr id="65" name="Imagem 64">
+            <a:extLst>
+              <a:ext uri="{FF2B5EF4-FFF2-40B4-BE49-F238E27FC236}">
+                <a16:creationId xmlns:a16="http://schemas.microsoft.com/office/drawing/2014/main" id="{EFDF2E75-84E2-68AC-9838-9A9D6E3DF09A}"/>
+              </a:ext>
+            </a:extLst>
+          </p:cNvPr>
+          <p:cNvPicPr>
+            <a:picLocks noChangeAspect="1"/>
+          </p:cNvPicPr>
+          <p:nvPr/>
+        </p:nvPicPr>
+        <p:blipFill>
+          <a:blip r:embed="rId4"/>
+          <a:stretch>
+            <a:fillRect/>
+          </a:stretch>
+        </p:blipFill>
+        <p:spPr>
+          <a:xfrm>
+            <a:off x="6096078" y="931170"/>
+            <a:ext cx="1890720" cy="2806434"/>
+          </a:xfrm>
+          <a:prstGeom prst="rect">
+            <a:avLst/>
+          </a:prstGeom>
+        </p:spPr>
+      </p:pic>
     </p:spTree>
   </p:cSld>
   <p:clrMapOvr>

</xml_diff>

<commit_message>
Adição do APK e pequena alteração na apresentação
</commit_message>
<xml_diff>
--- a/VitalRoutePPT.pptx
+++ b/VitalRoutePPT.pptx
@@ -9772,7 +9772,7 @@
           <a:bodyPr/>
           <a:lstStyle/>
           <a:p>
-            <a:endParaRPr lang="es-ES"/>
+            <a:endParaRPr lang="es-ES" u="sng" dirty="0"/>
           </a:p>
         </p:txBody>
       </p:sp>
@@ -9897,25 +9897,24 @@
         <p:spPr>
           <a:xfrm>
             <a:off x="5686425" y="4168378"/>
-            <a:ext cx="3000375" cy="119993"/>
-          </a:xfrm>
-          <a:prstGeom prst="rect">
-            <a:avLst/>
-          </a:prstGeom>
-          <a:noFill/>
-          <a:ln/>
-        </p:spPr>
-        <p:txBody>
-          <a:bodyPr wrap="none" lIns="0" tIns="0" rIns="0" bIns="0" rtlCol="0" anchor="t">
-            <a:spAutoFit/>
-          </a:bodyPr>
-          <a:lstStyle/>
-          <a:p>
-            <a:pPr marL="0" indent="0" algn="l">
+            <a:ext cx="3000375" cy="97912"/>
+          </a:xfrm>
+          <a:prstGeom prst="rect">
+            <a:avLst/>
+          </a:prstGeom>
+          <a:noFill/>
+          <a:ln/>
+        </p:spPr>
+        <p:txBody>
+          <a:bodyPr wrap="square" lIns="0" tIns="0" rIns="0" bIns="0" rtlCol="0" anchor="t">
+            <a:spAutoFit/>
+          </a:bodyPr>
+          <a:lstStyle/>
+          <a:p>
+            <a:pPr>
               <a:lnSpc>
                 <a:spcPct val="112000"/>
               </a:lnSpc>
-              <a:buNone/>
             </a:pPr>
             <a:r>
               <a:rPr lang="en-US" sz="600" b="1" kern="0" spc="1" dirty="0">
@@ -9926,7 +9925,7 @@
                 <a:ea typeface="Inter ExtraBold" pitchFamily="34" charset="-122"/>
                 <a:cs typeface="Inter ExtraBold" pitchFamily="34" charset="-120"/>
               </a:rPr>
-              <a:t>[URL DO GIT]</a:t>
+              <a:t>https://github.com/Duarte-Lourenco/ICM_2025-2026</a:t>
             </a:r>
             <a:endParaRPr lang="en-US" sz="600" dirty="0"/>
           </a:p>

</xml_diff>